<commit_message>
Slideshow: use the kiosk screenshots that landed; doc builder keeps line breaks as spaces
Co-Authored-By: Claude Fable 5.1 <noreply@anthropic.com>
</commit_message>
<xml_diff>
--- a/slides/pitch.pptx
+++ b/slides/pitch.pptx
@@ -3242,51 +3242,76 @@
         </p:nvSpPr>
         <p:spPr>
           <a:xfrm>
-            <a:off x="4937760" y="3520440"/>
-            <a:ext cx="3749040" cy="1097280"/>
+            <a:off x="4937760" y="3429000"/>
+            <a:ext cx="3749040" cy="1197864"/>
           </a:xfrm>
           <a:prstGeom prst="roundRect">
             <a:avLst>
-              <a:gd name="adj" fmla="val 5000"/>
+              <a:gd name="adj" fmla="val 4580"/>
             </a:avLst>
           </a:prstGeom>
           <a:solidFill>
-            <a:srgbClr val="EDE7DA"/>
+            <a:srgbClr val="FFFFFF"/>
+          </a:solidFill>
+          <a:ln w="9525">
+            <a:solidFill>
+              <a:srgbClr val="8A94A3"/>
+            </a:solidFill>
+            <a:prstDash val="solid"/>
+          </a:ln>
+        </p:spPr>
+      </p:sp>
+      <p:sp>
+        <p:nvSpPr>
+          <p:cNvPr id="11" name="Shape 8"/>
+          <p:cNvSpPr/>
+          <p:nvPr/>
+        </p:nvSpPr>
+        <p:spPr>
+          <a:xfrm>
+            <a:off x="4946904" y="3438144"/>
+            <a:ext cx="3730752" cy="219456"/>
+          </a:xfrm>
+          <a:prstGeom prst="rect">
+            <a:avLst/>
+          </a:prstGeom>
+          <a:solidFill>
+            <a:srgbClr val="E9E3D6"/>
           </a:solidFill>
           <a:ln w="12700">
             <a:solidFill>
-              <a:srgbClr val="546881"/>
+              <a:srgbClr val="E9E3D6"/>
             </a:solidFill>
-            <a:prstDash val="dash"/>
+            <a:prstDash val="solid"/>
           </a:ln>
         </p:spPr>
       </p:sp>
       <p:sp>
         <p:nvSpPr>
-          <p:cNvPr id="11" name="Text 8"/>
-          <p:cNvSpPr txBox="1"/>
-          <p:nvPr/>
-        </p:nvSpPr>
-        <p:spPr>
-          <a:xfrm>
-            <a:off x="4937760" y="3520440"/>
-            <a:ext cx="3749040" cy="1097280"/>
-          </a:xfrm>
-          <a:prstGeom prst="rect">
-            <a:avLst/>
-          </a:prstGeom>
-          <a:noFill/>
-          <a:ln/>
-        </p:spPr>
-        <p:txBody>
-          <a:bodyPr wrap="square" lIns="1270" tIns="1270" rIns="1270" bIns="1270" rtlCol="0" anchor="ctr"/>
-          <a:lstStyle/>
-          <a:p>
-            <a:pPr algn="ctr" indent="0" marL="0">
-              <a:buNone/>
-            </a:pPr>
-            <a:r>
-              <a:rPr lang="en-US" sz="750" spc="200" kern="0" dirty="0">
+          <p:cNvPr id="12" name="Text 9"/>
+          <p:cNvSpPr txBox="1"/>
+          <p:nvPr/>
+        </p:nvSpPr>
+        <p:spPr>
+          <a:xfrm>
+            <a:off x="5047488" y="3438144"/>
+            <a:ext cx="3529584" cy="219456"/>
+          </a:xfrm>
+          <a:prstGeom prst="rect">
+            <a:avLst/>
+          </a:prstGeom>
+          <a:noFill/>
+          <a:ln/>
+        </p:spPr>
+        <p:txBody>
+          <a:bodyPr wrap="square" lIns="0" tIns="0" rIns="0" bIns="0" rtlCol="0" anchor="ctr"/>
+          <a:lstStyle/>
+          <a:p>
+            <a:pPr indent="0" marL="0">
+              <a:buNone/>
+            </a:pPr>
+            <a:r>
+              <a:rPr lang="en-US" sz="750" dirty="0">
                 <a:solidFill>
                   <a:srgbClr val="546881"/>
                 </a:solidFill>
@@ -3294,39 +3319,35 @@
                 <a:ea typeface="Courier New" pitchFamily="34" charset="-122"/>
                 <a:cs typeface="Courier New" pitchFamily="34" charset="-120"/>
               </a:rPr>
-              <a:t>PHOTO COMING FROM THE KIOSK
-</a:t>
-            </a:r>
-            <a:pPr algn="ctr" indent="0" marL="0">
-              <a:buNone/>
-            </a:pPr>
-            <a:r>
-              <a:rPr lang="en-US" sz="1100" b="1" dirty="0">
-                <a:solidFill>
-                  <a:srgbClr val="1F3350"/>
-                </a:solidFill>
-              </a:rPr>
-              <a:t>A pilot’s FPV Journey badge map on the kiosk
-</a:t>
-            </a:r>
-            <a:pPr algn="ctr" indent="0" marL="0">
-              <a:buNone/>
-            </a:pPr>
-            <a:r>
-              <a:rPr lang="en-US" sz="700" dirty="0">
-                <a:solidFill>
-                  <a:srgbClr val="546881"/>
-                </a:solidFill>
-                <a:latin typeface="Courier New" pitchFamily="34" charset="0"/>
-                <a:ea typeface="Courier New" pitchFamily="34" charset="-122"/>
-                <a:cs typeface="Courier New" pitchFamily="34" charset="-120"/>
-              </a:rPr>
-              <a:t>kiosk/kiosk-journey.png</a:t>
+              <a:t>kiosk · a pilot’s badge map</a:t>
             </a:r>
             <a:endParaRPr lang="en-US" sz="750" dirty="0"/>
           </a:p>
         </p:txBody>
       </p:sp>
+      <p:pic>
+        <p:nvPicPr>
+          <p:cNvPr id="13" name="Image 0" descr="/private/tmp/claude-503/-Users-user-Documents-Workspace/77a334b4-d7cc-49da-a5bd-6abd8d6b9366/scratchpad/slides/img/kiosk-journey.png">    </p:cNvPr>
+          <p:cNvPicPr>
+            <a:picLocks noChangeAspect="1"/>
+          </p:cNvPicPr>
+          <p:nvPr/>
+        </p:nvPicPr>
+        <p:blipFill>
+          <a:blip r:embed="rId1"/>
+          <a:srcRect l="0" r="0" t="0" b="0"/>
+          <a:stretch/>
+        </p:blipFill>
+        <p:spPr>
+          <a:xfrm>
+            <a:off x="4974336" y="3685032"/>
+            <a:ext cx="3675888" cy="905256"/>
+          </a:xfrm>
+          <a:prstGeom prst="rect">
+            <a:avLst/>
+          </a:prstGeom>
+        </p:spPr>
+      </p:pic>
     </p:spTree>
   </p:cSld>
   <p:clrMapOvr>
@@ -11915,51 +11936,76 @@
         </p:nvSpPr>
         <p:spPr>
           <a:xfrm>
-            <a:off x="4937760" y="3611880"/>
-            <a:ext cx="3749040" cy="1005840"/>
+            <a:off x="4937760" y="3429000"/>
+            <a:ext cx="3749040" cy="1197864"/>
           </a:xfrm>
           <a:prstGeom prst="roundRect">
             <a:avLst>
-              <a:gd name="adj" fmla="val 5455"/>
+              <a:gd name="adj" fmla="val 4580"/>
             </a:avLst>
           </a:prstGeom>
           <a:solidFill>
-            <a:srgbClr val="EDE7DA"/>
+            <a:srgbClr val="FFFFFF"/>
+          </a:solidFill>
+          <a:ln w="9525">
+            <a:solidFill>
+              <a:srgbClr val="8A94A3"/>
+            </a:solidFill>
+            <a:prstDash val="solid"/>
+          </a:ln>
+        </p:spPr>
+      </p:sp>
+      <p:sp>
+        <p:nvSpPr>
+          <p:cNvPr id="13" name="Shape 9"/>
+          <p:cNvSpPr/>
+          <p:nvPr/>
+        </p:nvSpPr>
+        <p:spPr>
+          <a:xfrm>
+            <a:off x="4946904" y="3438144"/>
+            <a:ext cx="3730752" cy="219456"/>
+          </a:xfrm>
+          <a:prstGeom prst="rect">
+            <a:avLst/>
+          </a:prstGeom>
+          <a:solidFill>
+            <a:srgbClr val="E9E3D6"/>
           </a:solidFill>
           <a:ln w="12700">
             <a:solidFill>
-              <a:srgbClr val="546881"/>
+              <a:srgbClr val="E9E3D6"/>
             </a:solidFill>
-            <a:prstDash val="dash"/>
+            <a:prstDash val="solid"/>
           </a:ln>
         </p:spPr>
       </p:sp>
       <p:sp>
         <p:nvSpPr>
-          <p:cNvPr id="13" name="Text 9"/>
-          <p:cNvSpPr txBox="1"/>
-          <p:nvPr/>
-        </p:nvSpPr>
-        <p:spPr>
-          <a:xfrm>
-            <a:off x="4937760" y="3611880"/>
-            <a:ext cx="3749040" cy="1005840"/>
-          </a:xfrm>
-          <a:prstGeom prst="rect">
-            <a:avLst/>
-          </a:prstGeom>
-          <a:noFill/>
-          <a:ln/>
-        </p:spPr>
-        <p:txBody>
-          <a:bodyPr wrap="square" lIns="1270" tIns="1270" rIns="1270" bIns="1270" rtlCol="0" anchor="ctr"/>
-          <a:lstStyle/>
-          <a:p>
-            <a:pPr algn="ctr" indent="0" marL="0">
-              <a:buNone/>
-            </a:pPr>
-            <a:r>
-              <a:rPr lang="en-US" sz="750" spc="200" kern="0" dirty="0">
+          <p:cNvPr id="14" name="Text 10"/>
+          <p:cNvSpPr txBox="1"/>
+          <p:nvPr/>
+        </p:nvSpPr>
+        <p:spPr>
+          <a:xfrm>
+            <a:off x="5047488" y="3438144"/>
+            <a:ext cx="3529584" cy="219456"/>
+          </a:xfrm>
+          <a:prstGeom prst="rect">
+            <a:avLst/>
+          </a:prstGeom>
+          <a:noFill/>
+          <a:ln/>
+        </p:spPr>
+        <p:txBody>
+          <a:bodyPr wrap="square" lIns="0" tIns="0" rIns="0" bIns="0" rtlCol="0" anchor="ctr"/>
+          <a:lstStyle/>
+          <a:p>
+            <a:pPr indent="0" marL="0">
+              <a:buNone/>
+            </a:pPr>
+            <a:r>
+              <a:rPr lang="en-US" sz="750" dirty="0">
                 <a:solidFill>
                   <a:srgbClr val="546881"/>
                 </a:solidFill>
@@ -11967,39 +12013,35 @@
                 <a:ea typeface="Courier New" pitchFamily="34" charset="-122"/>
                 <a:cs typeface="Courier New" pitchFamily="34" charset="-120"/>
               </a:rPr>
-              <a:t>PHOTO COMING FROM THE KIOSK
-</a:t>
-            </a:r>
-            <a:pPr algn="ctr" indent="0" marL="0">
-              <a:buNone/>
-            </a:pPr>
-            <a:r>
-              <a:rPr lang="en-US" sz="1100" b="1" dirty="0">
-                <a:solidFill>
-                  <a:srgbClr val="1F3350"/>
-                </a:solidFill>
-              </a:rPr>
-              <a:t>A Flight School lesson open on the kiosk
-</a:t>
-            </a:r>
-            <a:pPr algn="ctr" indent="0" marL="0">
-              <a:buNone/>
-            </a:pPr>
-            <a:r>
-              <a:rPr lang="en-US" sz="700" dirty="0">
-                <a:solidFill>
-                  <a:srgbClr val="546881"/>
-                </a:solidFill>
-                <a:latin typeface="Courier New" pitchFamily="34" charset="0"/>
-                <a:ea typeface="Courier New" pitchFamily="34" charset="-122"/>
-                <a:cs typeface="Courier New" pitchFamily="34" charset="-120"/>
-              </a:rPr>
-              <a:t>kiosk/kiosk-lesson.png</a:t>
+              <a:t>kiosk · a lesson open</a:t>
             </a:r>
             <a:endParaRPr lang="en-US" sz="750" dirty="0"/>
           </a:p>
         </p:txBody>
       </p:sp>
+      <p:pic>
+        <p:nvPicPr>
+          <p:cNvPr id="15" name="Image 1" descr="/private/tmp/claude-503/-Users-user-Documents-Workspace/77a334b4-d7cc-49da-a5bd-6abd8d6b9366/scratchpad/slides/img/kiosk-lesson.png">    </p:cNvPr>
+          <p:cNvPicPr>
+            <a:picLocks noChangeAspect="1"/>
+          </p:cNvPicPr>
+          <p:nvPr/>
+        </p:nvPicPr>
+        <p:blipFill>
+          <a:blip r:embed="rId2"/>
+          <a:srcRect l="0" r="0" t="0" b="0"/>
+          <a:stretch/>
+        </p:blipFill>
+        <p:spPr>
+          <a:xfrm>
+            <a:off x="4974336" y="3685032"/>
+            <a:ext cx="3675888" cy="905256"/>
+          </a:xfrm>
+          <a:prstGeom prst="rect">
+            <a:avLst/>
+          </a:prstGeom>
+        </p:spPr>
+      </p:pic>
     </p:spTree>
   </p:cSld>
   <p:clrMapOvr>

</xml_diff>